<commit_message>
Update the deck for the three Nemotron roles, 18/18 claims, 69 tests and the committed live close
</commit_message>
<xml_diff>
--- a/deck/exhibit-a-deck.pptx
+++ b/deck/exhibit-a-deck.pptx
@@ -4313,7 +4313,7 @@
                 <a:ea typeface="Calibri" pitchFamily="34" charset="-122"/>
                 <a:cs typeface="Calibri" pitchFamily="34" charset="-120"/>
               </a:rPr>
-              <a:t>five causes</a:t>
+              <a:t>five causes, suspects from data</a:t>
             </a:r>
             <a:endParaRPr lang="en-US" sz="900" dirty="0"/>
           </a:p>
@@ -7519,29 +7519,19 @@
                 <a:ea typeface="Calibri" pitchFamily="34" charset="-122"/>
                 <a:cs typeface="Calibri" pitchFamily="34" charset="-120"/>
               </a:rPr>
-              <a:t>Nemotron critic</a:t>
+              <a:t>critic · safety · embed</a:t>
             </a:r>
             <a:endParaRPr lang="en-US" sz="1000" dirty="0"/>
           </a:p>
           <a:p>
-            <a:pPr indent="0" marL="0">
-              <a:lnSpc>
-                <a:spcPct val="110000"/>
-              </a:lnSpc>
-              <a:buNone/>
-            </a:pPr>
-            <a:r>
-              <a:rPr lang="en-US" sz="1000" dirty="0">
+            <a:r>
+              <a:rPr sz="1000">
                 <a:solidFill>
                   <a:srgbClr val="93A0B5"/>
                 </a:solidFill>
-                <a:latin typeface="Calibri" pitchFamily="34" charset="0"/>
-                <a:ea typeface="Calibri" pitchFamily="34" charset="-122"/>
-                <a:cs typeface="Calibri" pitchFamily="34" charset="-120"/>
-              </a:rPr>
-              <a:t>advisory only</a:t>
-            </a:r>
-            <a:endParaRPr lang="en-US" sz="1000" dirty="0"/>
+              </a:rPr>
+              <a:t>all bounded, replayable</a:t>
+            </a:r>
           </a:p>
         </p:txBody>
       </p:sp>
@@ -9394,7 +9384,7 @@
                 <a:ea typeface="Calibri" pitchFamily="34" charset="-122"/>
                 <a:cs typeface="Calibri" pitchFamily="34" charset="-120"/>
               </a:rPr>
-              <a:t>cold 0 hits → warm 1 hit</a:t>
+              <a:t>cold 0 hits → warm 1 hit · similarity 0.72</a:t>
             </a:r>
             <a:endParaRPr lang="en-US" sz="1000" dirty="0"/>
           </a:p>
@@ -9538,7 +9528,7 @@
                 <a:ea typeface="Calibri" pitchFamily="34" charset="-122"/>
                 <a:cs typeface="Calibri" pitchFamily="34" charset="-120"/>
               </a:rPr>
-              <a:t>context is bounded and visible</a:t>
+              <a:t>the exact windows are on the exhibit</a:t>
             </a:r>
             <a:endParaRPr lang="en-US" sz="1000" dirty="0"/>
           </a:p>
@@ -10044,7 +10034,7 @@
                 <a:ea typeface="Cambria" pitchFamily="34" charset="-122"/>
                 <a:cs typeface="Cambria" pitchFamily="34" charset="-120"/>
               </a:rPr>
-              <a:t>Adversarial review without model authority</a:t>
+              <a:t>Three bounded Nemotron roles</a:t>
             </a:r>
             <a:endParaRPr lang="en-US" sz="3200" dirty="0"/>
           </a:p>
@@ -10149,7 +10139,7 @@
                 <a:ea typeface="Calibri" pitchFamily="34" charset="-122"/>
                 <a:cs typeface="Calibri" pitchFamily="34" charset="-120"/>
               </a:rPr>
-              <a:t>Nemotron reads the evidence, hypotheses, counterfactual, and H-MEM hits. It returns objections, not verdicts.</a:t>
+              <a:t>Defense Counsel attacks each cause with JSON objections. Content safety labels the finding. Embeddings re-score H-MEM recall.</a:t>
             </a:r>
             <a:endParaRPr lang="en-US" sz="1400" dirty="0"/>
           </a:p>
@@ -10266,7 +10256,7 @@
                 <a:ea typeface="Cambria" pitchFamily="34" charset="-122"/>
                 <a:cs typeface="Cambria" pitchFamily="34" charset="-120"/>
               </a:rPr>
-              <a:t>2,599</a:t>
+              <a:t>2,620</a:t>
             </a:r>
             <a:endParaRPr lang="en-US" sz="4000" dirty="0"/>
           </a:p>
@@ -10344,7 +10334,7 @@
                 <a:ea typeface="Cambria" pitchFamily="34" charset="-122"/>
                 <a:cs typeface="Cambria" pitchFamily="34" charset="-120"/>
               </a:rPr>
-              <a:t>5,562</a:t>
+              <a:t>5,051</a:t>
             </a:r>
             <a:endParaRPr lang="en-US" sz="4000" dirty="0"/>
           </a:p>
@@ -10422,7 +10412,7 @@
                 <a:ea typeface="Calibri" pitchFamily="34" charset="-122"/>
                 <a:cs typeface="Calibri" pitchFamily="34" charset="-120"/>
               </a:rPr>
-              <a:t>The request excludes exhibit ids and timestamps, so the committed response is a true replay.</a:t>
+              <a:t>Requests exclude ids and timestamps; six recorded responses (cold and warm) replay exactly.</a:t>
             </a:r>
             <a:endParaRPr lang="en-US" sz="1100" dirty="0"/>
           </a:p>
@@ -10461,7 +10451,7 @@
                 <a:ea typeface="Calibri" pitchFamily="34" charset="-122"/>
                 <a:cs typeface="Calibri" pitchFamily="34" charset="-120"/>
               </a:rPr>
-              <a:t>Model: nvidia/nemotron-3-nano-omni-30b-a3b-reasoning</a:t>
+              <a:t>Critic nemotron-3-nano-omni-30b · Safety nemotron-3.5-content-safety · Recall nemotron-3.5-embed-1b</a:t>
             </a:r>
             <a:endParaRPr lang="en-US" sz="900" dirty="0"/>
           </a:p>
@@ -10836,7 +10826,7 @@
                 <a:ea typeface="Calibri" pitchFamily="34" charset="-122"/>
                 <a:cs typeface="Calibri" pitchFamily="34" charset="-120"/>
               </a:rPr>
-              <a:t>A deterministic lexical guard always runs.</a:t>
+              <a:t>Lexical guard plus the Nemotron content-safety model; either can withhold the finding.</a:t>
             </a:r>
             <a:endParaRPr lang="en-US" sz="1100" dirty="0"/>
           </a:p>
@@ -11223,7 +11213,7 @@
                 <a:ea typeface="Cambria" pitchFamily="34" charset="-122"/>
                 <a:cs typeface="Cambria" pitchFamily="34" charset="-120"/>
               </a:rPr>
-              <a:t>14/14</a:t>
+              <a:t>18/18</a:t>
             </a:r>
             <a:endParaRPr lang="en-US" sz="4000" dirty="0"/>
           </a:p>
@@ -11328,7 +11318,7 @@
                 <a:ea typeface="Cambria" pitchFamily="34" charset="-122"/>
                 <a:cs typeface="Cambria" pitchFamily="34" charset="-120"/>
               </a:rPr>
-              <a:t>65</a:t>
+              <a:t>69</a:t>
             </a:r>
             <a:endParaRPr lang="en-US" sz="4000" dirty="0"/>
           </a:p>
@@ -11931,7 +11921,7 @@
                 <a:ea typeface="Calibri" pitchFamily="34" charset="-122"/>
                 <a:cs typeface="Calibri" pitchFamily="34" charset="-120"/>
               </a:rPr>
-              <a:t>The sample is labelled replay. The live case is evidence from a local Zetaris instance; it is not presented as a live demo here.</a:t>
+              <a:t>The sample is labelled replay. The live close is committed under fixtures/cases/live and is the first case in the viewer.</a:t>
             </a:r>
             <a:endParaRPr lang="en-US" sz="1000" dirty="0"/>
           </a:p>

</xml_diff>